<commit_message>
docs: deck layout fixes + Grant Pitch Deck V4 (three flavors)
Portfolio Deck V10 (updated in place): milestones column on the revenue
slide ran 0.6in past the right edge — capped to fit the margin. Verified
zero canvas-overflow violations via geometry audit of every element.

Grant Pitch Deck V4 (July 2026, replaces June V3 file): the dedicated
Grant-system deck alongside the portfolio deck.
- Slide 6 rebuilt: 'Two flavors' -> three-card 'Three operating modes'
  (Closed Network / Direct Compliance / Crisis-Context Fund).
- New slide 11 'Flavor 3 — Crisis-Context Fund' with the Proximate
  reference panel; footers + chapter marks renumbered (21 slides).
- Feature matrix compressed (rows/legend previously ran past the bottom
  edge of the slide); zero overflow violations after fix.

Cohesion Brief updated to reference Grant Deck V4.

Co-Authored-By: Claude Fable 5 <noreply@anthropic.com>
</commit_message>
<xml_diff>
--- a/docs/Kuja_Pitch_Deck_V10_Professional_July2026.pptx
+++ b/docs/Kuja_Pitch_Deck_V10_Professional_July2026.pptx
@@ -11580,7 +11580,7 @@
         <p:spPr>
           <a:xfrm>
             <a:off x="9539935" y="3017520"/>
-            <a:ext cx="3657600" cy="274320"/>
+            <a:ext cx="2011680" cy="274320"/>
           </a:xfrm>
           <a:prstGeom prst="rect">
             <a:avLst/>
@@ -11619,7 +11619,7 @@
         <p:spPr>
           <a:xfrm>
             <a:off x="9539935" y="3383280"/>
-            <a:ext cx="3200400" cy="274320"/>
+            <a:ext cx="2011680" cy="274320"/>
           </a:xfrm>
           <a:prstGeom prst="rect">
             <a:avLst/>
@@ -11658,7 +11658,7 @@
         <p:spPr>
           <a:xfrm>
             <a:off x="9539935" y="3657600"/>
-            <a:ext cx="3200400" cy="274320"/>
+            <a:ext cx="2011680" cy="274320"/>
           </a:xfrm>
           <a:prstGeom prst="rect">
             <a:avLst/>
@@ -11697,7 +11697,7 @@
         <p:spPr>
           <a:xfrm>
             <a:off x="9539935" y="4023360"/>
-            <a:ext cx="3200400" cy="274320"/>
+            <a:ext cx="2011680" cy="274320"/>
           </a:xfrm>
           <a:prstGeom prst="rect">
             <a:avLst/>
@@ -11736,7 +11736,7 @@
         <p:spPr>
           <a:xfrm>
             <a:off x="9539935" y="4297680"/>
-            <a:ext cx="3200400" cy="274320"/>
+            <a:ext cx="2011680" cy="274320"/>
           </a:xfrm>
           <a:prstGeom prst="rect">
             <a:avLst/>
@@ -11775,7 +11775,7 @@
         <p:spPr>
           <a:xfrm>
             <a:off x="9539935" y="4663440"/>
-            <a:ext cx="3200400" cy="274320"/>
+            <a:ext cx="2011680" cy="274320"/>
           </a:xfrm>
           <a:prstGeom prst="rect">
             <a:avLst/>
@@ -11814,7 +11814,7 @@
         <p:spPr>
           <a:xfrm>
             <a:off x="9539935" y="4937760"/>
-            <a:ext cx="3200400" cy="274320"/>
+            <a:ext cx="2011680" cy="274320"/>
           </a:xfrm>
           <a:prstGeom prst="rect">
             <a:avLst/>

</xml_diff>